<commit_message>
fix(deck): correct rendered layout defects in technical review deck
First render-verified pass on this deck (LibreOffice filters were missing
from the container until now, so earlier checks were schema-only).

- Slide 5/8: accent fill computed as bright cyan (81F0EC) instead of the
  intended soft mint (E0F0EC); replaced the derived value with a literal
- Slide 1: title wrapped to two lines and collided with the subtitle
- Slide 3: dark-band headline wrapped into the body text
- Slide 6: side-card body clipped at the card boundary
- Slide 10: closing band overlapped row three, clipping question 6
- Footers reflowed away from the slide edge

Schema validation passes; all ten slides visually inspected.

Co-Authored-By: Claude Opus 5 <noreply@anthropic.com>
Claude-Session: https://claude.ai/code/session_019fsE75rUMhbGKnrp5V9C69
</commit_message>
<xml_diff>
--- a/docs/Triage_Benchmark_Technical_Review.pptx
+++ b/docs/Triage_Benchmark_Technical_Review.pptx
@@ -1724,23 +1724,23 @@
         <p:spPr>
           <a:xfrm>
             <a:off x="548640" y="1097280"/>
-            <a:ext cx="11091672" cy="868680"/>
-          </a:xfrm>
-          <a:prstGeom prst="rect">
-            <a:avLst/>
-          </a:prstGeom>
-          <a:noFill/>
-          <a:ln/>
-        </p:spPr>
-        <p:txBody>
-          <a:bodyPr wrap="square" lIns="0" tIns="0" rIns="0" bIns="0" rtlCol="0" anchor="ctr"/>
-          <a:lstStyle/>
-          <a:p>
-            <a:pPr indent="0" marL="0">
-              <a:buNone/>
-            </a:pPr>
-            <a:r>
-              <a:rPr lang="en-US" sz="3600" b="1" dirty="0">
+            <a:ext cx="11091672" cy="1051560"/>
+          </a:xfrm>
+          <a:prstGeom prst="rect">
+            <a:avLst/>
+          </a:prstGeom>
+          <a:noFill/>
+          <a:ln/>
+        </p:spPr>
+        <p:txBody>
+          <a:bodyPr wrap="square" lIns="0" tIns="0" rIns="0" bIns="0" rtlCol="0" anchor="t"/>
+          <a:lstStyle/>
+          <a:p>
+            <a:pPr indent="0" marL="0">
+              <a:buNone/>
+            </a:pPr>
+            <a:r>
+              <a:rPr lang="en-US" sz="3300" b="1" dirty="0">
                 <a:solidFill>
                   <a:srgbClr val="FFFFFF"/>
                 </a:solidFill>
@@ -1750,7 +1750,7 @@
               </a:rPr>
               <a:t>Measuring Disposition Safety in Patient-Facing LLMs</a:t>
             </a:r>
-            <a:endParaRPr lang="en-US" sz="3600" dirty="0"/>
+            <a:endParaRPr lang="en-US" sz="3300" dirty="0"/>
           </a:p>
         </p:txBody>
       </p:sp>
@@ -1762,24 +1762,24 @@
         </p:nvSpPr>
         <p:spPr>
           <a:xfrm>
-            <a:off x="548640" y="1965960"/>
-            <a:ext cx="9692640" cy="548640"/>
-          </a:xfrm>
-          <a:prstGeom prst="rect">
-            <a:avLst/>
-          </a:prstGeom>
-          <a:noFill/>
-          <a:ln/>
-        </p:spPr>
-        <p:txBody>
-          <a:bodyPr wrap="square" lIns="0" tIns="0" rIns="0" bIns="0" rtlCol="0" anchor="ctr"/>
-          <a:lstStyle/>
-          <a:p>
-            <a:pPr indent="0" marL="0">
-              <a:buNone/>
-            </a:pPr>
-            <a:r>
-              <a:rPr lang="en-US" sz="1500" i="1" dirty="0">
+            <a:off x="548640" y="2212848"/>
+            <a:ext cx="10241280" cy="502920"/>
+          </a:xfrm>
+          <a:prstGeom prst="rect">
+            <a:avLst/>
+          </a:prstGeom>
+          <a:noFill/>
+          <a:ln/>
+        </p:spPr>
+        <p:txBody>
+          <a:bodyPr wrap="square" lIns="0" tIns="0" rIns="0" bIns="0" rtlCol="0" anchor="t"/>
+          <a:lstStyle/>
+          <a:p>
+            <a:pPr indent="0" marL="0">
+              <a:buNone/>
+            </a:pPr>
+            <a:r>
+              <a:rPr lang="en-US" sz="1450" i="1" dirty="0">
                 <a:solidFill>
                   <a:srgbClr val="BFD0DD"/>
                 </a:solidFill>
@@ -1789,7 +1789,7 @@
               </a:rPr>
               <a:t>A physician-authored, contamination-audited triage benchmark — and the methodological questions we want you to attack</a:t>
             </a:r>
-            <a:endParaRPr lang="en-US" sz="1500" dirty="0"/>
+            <a:endParaRPr lang="en-US" sz="1450" dirty="0"/>
           </a:p>
         </p:txBody>
       </p:sp>
@@ -2367,12 +2367,12 @@
         </p:nvSpPr>
         <p:spPr>
           <a:xfrm>
-            <a:off x="548640" y="1554480"/>
-            <a:ext cx="5340096" cy="1417320"/>
+            <a:off x="548640" y="1481328"/>
+            <a:ext cx="5340096" cy="1225296"/>
           </a:xfrm>
           <a:prstGeom prst="roundRect">
             <a:avLst>
-              <a:gd name="adj" fmla="val 4516"/>
+              <a:gd name="adj" fmla="val 5224"/>
             </a:avLst>
           </a:prstGeom>
           <a:solidFill>
@@ -2394,7 +2394,7 @@
         </p:nvSpPr>
         <p:spPr>
           <a:xfrm>
-            <a:off x="731520" y="1737360"/>
+            <a:off x="731520" y="1664208"/>
             <a:ext cx="347472" cy="347472"/>
           </a:xfrm>
           <a:prstGeom prst="ellipse">
@@ -2414,7 +2414,7 @@
         </p:nvSpPr>
         <p:spPr>
           <a:xfrm>
-            <a:off x="731520" y="1737360"/>
+            <a:off x="731520" y="1664208"/>
             <a:ext cx="347472" cy="347472"/>
           </a:xfrm>
           <a:prstGeom prst="rect">
@@ -2453,7 +2453,7 @@
         </p:nvSpPr>
         <p:spPr>
           <a:xfrm>
-            <a:off x="1188720" y="1709928"/>
+            <a:off x="1188720" y="1636776"/>
             <a:ext cx="4471416" cy="292608"/>
           </a:xfrm>
           <a:prstGeom prst="rect">
@@ -2492,8 +2492,8 @@
         </p:nvSpPr>
         <p:spPr>
           <a:xfrm>
-            <a:off x="1188720" y="2029968"/>
-            <a:ext cx="4471416" cy="841248"/>
+            <a:off x="1188720" y="1938528"/>
+            <a:ext cx="4471416" cy="713232"/>
           </a:xfrm>
           <a:prstGeom prst="rect">
             <a:avLst/>
@@ -2509,7 +2509,7 @@
               <a:buNone/>
             </a:pPr>
             <a:r>
-              <a:rPr lang="en-US" sz="980" dirty="0">
+              <a:rPr lang="en-US" sz="950" dirty="0">
                 <a:solidFill>
                   <a:srgbClr val="5A6B7C"/>
                 </a:solidFill>
@@ -2519,7 +2519,7 @@
               </a:rPr>
               <a:t>The primary endpoint rests on deterministic detection of explicit escalation in free text. What is the right validation design against paraphrase and hedged escalation — and what recall floor should we pre-register?</a:t>
             </a:r>
-            <a:endParaRPr lang="en-US" sz="980" dirty="0"/>
+            <a:endParaRPr lang="en-US" sz="950" dirty="0"/>
           </a:p>
         </p:txBody>
       </p:sp>
@@ -2531,12 +2531,12 @@
         </p:nvSpPr>
         <p:spPr>
           <a:xfrm>
-            <a:off x="6300216" y="1554480"/>
-            <a:ext cx="5340096" cy="1417320"/>
+            <a:off x="6300216" y="1481328"/>
+            <a:ext cx="5340096" cy="1225296"/>
           </a:xfrm>
           <a:prstGeom prst="roundRect">
             <a:avLst>
-              <a:gd name="adj" fmla="val 4516"/>
+              <a:gd name="adj" fmla="val 5224"/>
             </a:avLst>
           </a:prstGeom>
           <a:solidFill>
@@ -2558,7 +2558,7 @@
         </p:nvSpPr>
         <p:spPr>
           <a:xfrm>
-            <a:off x="6483096" y="1737360"/>
+            <a:off x="6483096" y="1664208"/>
             <a:ext cx="347472" cy="347472"/>
           </a:xfrm>
           <a:prstGeom prst="ellipse">
@@ -2578,7 +2578,7 @@
         </p:nvSpPr>
         <p:spPr>
           <a:xfrm>
-            <a:off x="6483096" y="1737360"/>
+            <a:off x="6483096" y="1664208"/>
             <a:ext cx="347472" cy="347472"/>
           </a:xfrm>
           <a:prstGeom prst="rect">
@@ -2617,7 +2617,7 @@
         </p:nvSpPr>
         <p:spPr>
           <a:xfrm>
-            <a:off x="6940296" y="1709928"/>
+            <a:off x="6940296" y="1636776"/>
             <a:ext cx="4471416" cy="292608"/>
           </a:xfrm>
           <a:prstGeom prst="rect">
@@ -2656,8 +2656,8 @@
         </p:nvSpPr>
         <p:spPr>
           <a:xfrm>
-            <a:off x="6940296" y="2029968"/>
-            <a:ext cx="4471416" cy="841248"/>
+            <a:off x="6940296" y="1938528"/>
+            <a:ext cx="4471416" cy="713232"/>
           </a:xfrm>
           <a:prstGeom prst="rect">
             <a:avLst/>
@@ -2673,7 +2673,7 @@
               <a:buNone/>
             </a:pPr>
             <a:r>
-              <a:rPr lang="en-US" sz="980" dirty="0">
+              <a:rPr lang="en-US" sz="950" dirty="0">
                 <a:solidFill>
                   <a:srgbClr val="5A6B7C"/>
                 </a:solidFill>
@@ -2683,7 +2683,7 @@
               </a:rPr>
               <a:t>Three cross-vendor judges cannot fully diagnose their own correlated error. Is there a practical estimator with a panel this small, or do we need a held-out human-labelled stratum sized for it?</a:t>
             </a:r>
-            <a:endParaRPr lang="en-US" sz="980" dirty="0"/>
+            <a:endParaRPr lang="en-US" sz="950" dirty="0"/>
           </a:p>
         </p:txBody>
       </p:sp>
@@ -2695,12 +2695,12 @@
         </p:nvSpPr>
         <p:spPr>
           <a:xfrm>
-            <a:off x="548640" y="3127248"/>
-            <a:ext cx="5340096" cy="1417320"/>
+            <a:off x="548640" y="2834640"/>
+            <a:ext cx="5340096" cy="1225296"/>
           </a:xfrm>
           <a:prstGeom prst="roundRect">
             <a:avLst>
-              <a:gd name="adj" fmla="val 4516"/>
+              <a:gd name="adj" fmla="val 5224"/>
             </a:avLst>
           </a:prstGeom>
           <a:solidFill>
@@ -2722,7 +2722,7 @@
         </p:nvSpPr>
         <p:spPr>
           <a:xfrm>
-            <a:off x="731520" y="3310128"/>
+            <a:off x="731520" y="3017520"/>
             <a:ext cx="347472" cy="347472"/>
           </a:xfrm>
           <a:prstGeom prst="ellipse">
@@ -2742,7 +2742,7 @@
         </p:nvSpPr>
         <p:spPr>
           <a:xfrm>
-            <a:off x="731520" y="3310128"/>
+            <a:off x="731520" y="3017520"/>
             <a:ext cx="347472" cy="347472"/>
           </a:xfrm>
           <a:prstGeom prst="rect">
@@ -2781,7 +2781,7 @@
         </p:nvSpPr>
         <p:spPr>
           <a:xfrm>
-            <a:off x="1188720" y="3282696"/>
+            <a:off x="1188720" y="2990088"/>
             <a:ext cx="4471416" cy="292608"/>
           </a:xfrm>
           <a:prstGeom prst="rect">
@@ -2820,8 +2820,8 @@
         </p:nvSpPr>
         <p:spPr>
           <a:xfrm>
-            <a:off x="1188720" y="3602736"/>
-            <a:ext cx="4471416" cy="841248"/>
+            <a:off x="1188720" y="3291840"/>
+            <a:ext cx="4471416" cy="713232"/>
           </a:xfrm>
           <a:prstGeom prst="rect">
             <a:avLst/>
@@ -2837,7 +2837,7 @@
               <a:buNone/>
             </a:pPr>
             <a:r>
-              <a:rPr lang="en-US" sz="980" dirty="0">
+              <a:rPr lang="en-US" sz="950" dirty="0">
                 <a:solidFill>
                   <a:srgbClr val="5A6B7C"/>
                 </a:solidFill>
@@ -2847,7 +2847,7 @@
               </a:rPr>
               <a:t>Given that surface perturbation reliably fails, what probe construction and detection statistic would actually convince you that memorization is or is not operating?</a:t>
             </a:r>
-            <a:endParaRPr lang="en-US" sz="980" dirty="0"/>
+            <a:endParaRPr lang="en-US" sz="950" dirty="0"/>
           </a:p>
         </p:txBody>
       </p:sp>
@@ -2859,12 +2859,12 @@
         </p:nvSpPr>
         <p:spPr>
           <a:xfrm>
-            <a:off x="6300216" y="3127248"/>
-            <a:ext cx="5340096" cy="1417320"/>
+            <a:off x="6300216" y="2834640"/>
+            <a:ext cx="5340096" cy="1225296"/>
           </a:xfrm>
           <a:prstGeom prst="roundRect">
             <a:avLst>
-              <a:gd name="adj" fmla="val 4516"/>
+              <a:gd name="adj" fmla="val 5224"/>
             </a:avLst>
           </a:prstGeom>
           <a:solidFill>
@@ -2886,7 +2886,7 @@
         </p:nvSpPr>
         <p:spPr>
           <a:xfrm>
-            <a:off x="6483096" y="3310128"/>
+            <a:off x="6483096" y="3017520"/>
             <a:ext cx="347472" cy="347472"/>
           </a:xfrm>
           <a:prstGeom prst="ellipse">
@@ -2906,7 +2906,7 @@
         </p:nvSpPr>
         <p:spPr>
           <a:xfrm>
-            <a:off x="6483096" y="3310128"/>
+            <a:off x="6483096" y="3017520"/>
             <a:ext cx="347472" cy="347472"/>
           </a:xfrm>
           <a:prstGeom prst="rect">
@@ -2945,7 +2945,7 @@
         </p:nvSpPr>
         <p:spPr>
           <a:xfrm>
-            <a:off x="6940296" y="3282696"/>
+            <a:off x="6940296" y="2990088"/>
             <a:ext cx="4471416" cy="292608"/>
           </a:xfrm>
           <a:prstGeom prst="rect">
@@ -2984,8 +2984,8 @@
         </p:nvSpPr>
         <p:spPr>
           <a:xfrm>
-            <a:off x="6940296" y="3602736"/>
-            <a:ext cx="4471416" cy="841248"/>
+            <a:off x="6940296" y="3291840"/>
+            <a:ext cx="4471416" cy="713232"/>
           </a:xfrm>
           <a:prstGeom prst="rect">
             <a:avLst/>
@@ -3001,7 +3001,7 @@
               <a:buNone/>
             </a:pPr>
             <a:r>
-              <a:rPr lang="en-US" sz="980" dirty="0">
+              <a:rPr lang="en-US" sz="950" dirty="0">
                 <a:solidFill>
                   <a:srgbClr val="5A6B7C"/>
                 </a:solidFill>
@@ -3011,7 +3011,7 @@
               </a:rPr>
               <a:t>For run-to-run variation: majority-agreement rate, entropy over the disposition distribution, or per-cell variance — and how many runs to estimate it stably at n = 50 scenarios?</a:t>
             </a:r>
-            <a:endParaRPr lang="en-US" sz="980" dirty="0"/>
+            <a:endParaRPr lang="en-US" sz="950" dirty="0"/>
           </a:p>
         </p:txBody>
       </p:sp>
@@ -3023,12 +3023,12 @@
         </p:nvSpPr>
         <p:spPr>
           <a:xfrm>
-            <a:off x="548640" y="4700016"/>
-            <a:ext cx="5340096" cy="1417320"/>
+            <a:off x="548640" y="4187952"/>
+            <a:ext cx="5340096" cy="1225296"/>
           </a:xfrm>
           <a:prstGeom prst="roundRect">
             <a:avLst>
-              <a:gd name="adj" fmla="val 4516"/>
+              <a:gd name="adj" fmla="val 5224"/>
             </a:avLst>
           </a:prstGeom>
           <a:solidFill>
@@ -3050,7 +3050,7 @@
         </p:nvSpPr>
         <p:spPr>
           <a:xfrm>
-            <a:off x="731520" y="4882896"/>
+            <a:off x="731520" y="4370832"/>
             <a:ext cx="347472" cy="347472"/>
           </a:xfrm>
           <a:prstGeom prst="ellipse">
@@ -3070,7 +3070,7 @@
         </p:nvSpPr>
         <p:spPr>
           <a:xfrm>
-            <a:off x="731520" y="4882896"/>
+            <a:off x="731520" y="4370832"/>
             <a:ext cx="347472" cy="347472"/>
           </a:xfrm>
           <a:prstGeom prst="rect">
@@ -3109,7 +3109,7 @@
         </p:nvSpPr>
         <p:spPr>
           <a:xfrm>
-            <a:off x="1188720" y="4855464"/>
+            <a:off x="1188720" y="4343400"/>
             <a:ext cx="4471416" cy="292608"/>
           </a:xfrm>
           <a:prstGeom prst="rect">
@@ -3148,8 +3148,8 @@
         </p:nvSpPr>
         <p:spPr>
           <a:xfrm>
-            <a:off x="1188720" y="5175504"/>
-            <a:ext cx="4471416" cy="841248"/>
+            <a:off x="1188720" y="4645152"/>
+            <a:ext cx="4471416" cy="713232"/>
           </a:xfrm>
           <a:prstGeom prst="rect">
             <a:avLst/>
@@ -3165,7 +3165,7 @@
               <a:buNone/>
             </a:pPr>
             <a:r>
-              <a:rPr lang="en-US" sz="980" dirty="0">
+              <a:rPr lang="en-US" sz="950" dirty="0">
                 <a:solidFill>
                   <a:srgbClr val="5A6B7C"/>
                 </a:solidFill>
@@ -3175,7 +3175,7 @@
               </a:rPr>
               <a:t>What discordance rate should the pilot be designed to detect, and how many matched pairs before a McNemar power calculation is honest?</a:t>
             </a:r>
-            <a:endParaRPr lang="en-US" sz="980" dirty="0"/>
+            <a:endParaRPr lang="en-US" sz="950" dirty="0"/>
           </a:p>
         </p:txBody>
       </p:sp>
@@ -3187,12 +3187,12 @@
         </p:nvSpPr>
         <p:spPr>
           <a:xfrm>
-            <a:off x="6300216" y="4700016"/>
-            <a:ext cx="5340096" cy="1417320"/>
+            <a:off x="6300216" y="4187952"/>
+            <a:ext cx="5340096" cy="1225296"/>
           </a:xfrm>
           <a:prstGeom prst="roundRect">
             <a:avLst>
-              <a:gd name="adj" fmla="val 4516"/>
+              <a:gd name="adj" fmla="val 5224"/>
             </a:avLst>
           </a:prstGeom>
           <a:solidFill>
@@ -3214,7 +3214,7 @@
         </p:nvSpPr>
         <p:spPr>
           <a:xfrm>
-            <a:off x="6483096" y="4882896"/>
+            <a:off x="6483096" y="4370832"/>
             <a:ext cx="347472" cy="347472"/>
           </a:xfrm>
           <a:prstGeom prst="ellipse">
@@ -3234,7 +3234,7 @@
         </p:nvSpPr>
         <p:spPr>
           <a:xfrm>
-            <a:off x="6483096" y="4882896"/>
+            <a:off x="6483096" y="4370832"/>
             <a:ext cx="347472" cy="347472"/>
           </a:xfrm>
           <a:prstGeom prst="rect">
@@ -3273,7 +3273,7 @@
         </p:nvSpPr>
         <p:spPr>
           <a:xfrm>
-            <a:off x="6940296" y="4855464"/>
+            <a:off x="6940296" y="4343400"/>
             <a:ext cx="4471416" cy="292608"/>
           </a:xfrm>
           <a:prstGeom prst="rect">
@@ -3312,8 +3312,8 @@
         </p:nvSpPr>
         <p:spPr>
           <a:xfrm>
-            <a:off x="6940296" y="5175504"/>
-            <a:ext cx="4471416" cy="841248"/>
+            <a:off x="6940296" y="4645152"/>
+            <a:ext cx="4471416" cy="713232"/>
           </a:xfrm>
           <a:prstGeom prst="rect">
             <a:avLst/>
@@ -3329,7 +3329,7 @@
               <a:buNone/>
             </a:pPr>
             <a:r>
-              <a:rPr lang="en-US" sz="980" dirty="0">
+              <a:rPr lang="en-US" sz="950" dirty="0">
                 <a:solidFill>
                   <a:srgbClr val="5A6B7C"/>
                 </a:solidFill>
@@ -3339,7 +3339,7 @@
               </a:rPr>
               <a:t>How would you demonstrate that lay and expert formulations are clinically content-equivalent rather than differing in difficulty — without leaking the answer to the models?</a:t>
             </a:r>
-            <a:endParaRPr lang="en-US" sz="980" dirty="0"/>
+            <a:endParaRPr lang="en-US" sz="950" dirty="0"/>
           </a:p>
         </p:txBody>
       </p:sp>
@@ -3351,12 +3351,12 @@
         </p:nvSpPr>
         <p:spPr>
           <a:xfrm>
-            <a:off x="548640" y="5532120"/>
-            <a:ext cx="11091672" cy="685800"/>
+            <a:off x="548640" y="5650992"/>
+            <a:ext cx="11091672" cy="658368"/>
           </a:xfrm>
           <a:prstGeom prst="roundRect">
             <a:avLst>
-              <a:gd name="adj" fmla="val 9333"/>
+              <a:gd name="adj" fmla="val 9722"/>
             </a:avLst>
           </a:prstGeom>
           <a:solidFill>
@@ -3373,24 +3373,24 @@
         </p:nvSpPr>
         <p:spPr>
           <a:xfrm>
-            <a:off x="822960" y="5532120"/>
-            <a:ext cx="10543032" cy="685800"/>
-          </a:xfrm>
-          <a:prstGeom prst="rect">
-            <a:avLst/>
-          </a:prstGeom>
-          <a:noFill/>
-          <a:ln/>
-        </p:spPr>
-        <p:txBody>
-          <a:bodyPr wrap="square" lIns="0" tIns="0" rIns="0" bIns="0" rtlCol="0" anchor="ctr"/>
-          <a:lstStyle/>
-          <a:p>
-            <a:pPr indent="0" marL="0">
-              <a:buNone/>
-            </a:pPr>
-            <a:r>
-              <a:rPr lang="en-US" sz="1400" b="1" dirty="0">
+            <a:off x="822960" y="5650992"/>
+            <a:ext cx="10543032" cy="658368"/>
+          </a:xfrm>
+          <a:prstGeom prst="rect">
+            <a:avLst/>
+          </a:prstGeom>
+          <a:noFill/>
+          <a:ln/>
+        </p:spPr>
+        <p:txBody>
+          <a:bodyPr wrap="square" lIns="0" tIns="0" rIns="0" bIns="0" rtlCol="0" anchor="ctr"/>
+          <a:lstStyle/>
+          <a:p>
+            <a:pPr indent="0" marL="0">
+              <a:buNone/>
+            </a:pPr>
+            <a:r>
+              <a:rPr lang="en-US" sz="1300" b="1" dirty="0">
                 <a:solidFill>
                   <a:srgbClr val="FFFFFF"/>
                 </a:solidFill>
@@ -3398,9 +3398,9 @@
                 <a:ea typeface="Cambria" pitchFamily="34" charset="-122"/>
                 <a:cs typeface="Cambria" pitchFamily="34" charset="-120"/>
               </a:rPr>
-              <a:t>Nothing is filed. The protocol number field is still blank — changes made now cost a redraft, not an amendment.</a:t>
-            </a:r>
-            <a:endParaRPr lang="en-US" sz="1400" dirty="0"/>
+              <a:t>Nothing is filed. The protocol number field is still blank — changes now cost a redraft, not an amendment.</a:t>
+            </a:r>
+            <a:endParaRPr lang="en-US" sz="1300" dirty="0"/>
           </a:p>
         </p:txBody>
       </p:sp>
@@ -4029,24 +4029,24 @@
         </p:nvSpPr>
         <p:spPr>
           <a:xfrm>
-            <a:off x="548640" y="6400800"/>
-            <a:ext cx="11091672" cy="310896"/>
-          </a:xfrm>
-          <a:prstGeom prst="rect">
-            <a:avLst/>
-          </a:prstGeom>
-          <a:noFill/>
-          <a:ln/>
-        </p:spPr>
-        <p:txBody>
-          <a:bodyPr wrap="square" lIns="0" tIns="0" rIns="0" bIns="0" rtlCol="0" anchor="ctr"/>
-          <a:lstStyle/>
-          <a:p>
-            <a:pPr indent="0" marL="0">
-              <a:buNone/>
-            </a:pPr>
-            <a:r>
-              <a:rPr lang="en-US" sz="900" dirty="0">
+            <a:off x="548640" y="6309360"/>
+            <a:ext cx="11091672" cy="411480"/>
+          </a:xfrm>
+          <a:prstGeom prst="rect">
+            <a:avLst/>
+          </a:prstGeom>
+          <a:noFill/>
+          <a:ln/>
+        </p:spPr>
+        <p:txBody>
+          <a:bodyPr wrap="square" lIns="0" tIns="0" rIns="0" bIns="0" rtlCol="0" anchor="ctr"/>
+          <a:lstStyle/>
+          <a:p>
+            <a:pPr indent="0" marL="0">
+              <a:buNone/>
+            </a:pPr>
+            <a:r>
+              <a:rPr lang="en-US" sz="850" dirty="0">
                 <a:solidFill>
                   <a:srgbClr val="5A6B7C"/>
                 </a:solidFill>
@@ -4056,7 +4056,7 @@
               </a:rPr>
               <a:t>Singh et al., Sci Rep 2025 (FreeMedQA) · Wu/Nateghi Haredasht et al., NOHARM, arXiv 2512.01241 v1, preprint · American College of Surgeons, Resources for Optimal Care of the Injured Patient.</a:t>
             </a:r>
-            <a:endParaRPr lang="en-US" sz="900" dirty="0"/>
+            <a:endParaRPr lang="en-US" sz="850" dirty="0"/>
           </a:p>
         </p:txBody>
       </p:sp>
@@ -4932,24 +4932,24 @@
         </p:nvSpPr>
         <p:spPr>
           <a:xfrm>
-            <a:off x="804672" y="4736592"/>
-            <a:ext cx="10579608" cy="320040"/>
-          </a:xfrm>
-          <a:prstGeom prst="rect">
-            <a:avLst/>
-          </a:prstGeom>
-          <a:noFill/>
-          <a:ln/>
-        </p:spPr>
-        <p:txBody>
-          <a:bodyPr wrap="square" lIns="0" tIns="0" rIns="0" bIns="0" rtlCol="0" anchor="ctr"/>
-          <a:lstStyle/>
-          <a:p>
-            <a:pPr indent="0" marL="0">
-              <a:buNone/>
-            </a:pPr>
-            <a:r>
-              <a:rPr lang="en-US" sz="1500" b="1" dirty="0">
+            <a:off x="804672" y="4718304"/>
+            <a:ext cx="10579608" cy="329184"/>
+          </a:xfrm>
+          <a:prstGeom prst="rect">
+            <a:avLst/>
+          </a:prstGeom>
+          <a:noFill/>
+          <a:ln/>
+        </p:spPr>
+        <p:txBody>
+          <a:bodyPr wrap="square" lIns="0" tIns="0" rIns="0" bIns="0" rtlCol="0" anchor="ctr"/>
+          <a:lstStyle/>
+          <a:p>
+            <a:pPr indent="0" marL="0">
+              <a:buNone/>
+            </a:pPr>
+            <a:r>
+              <a:rPr lang="en-US" sz="1450" b="1" dirty="0">
                 <a:solidFill>
                   <a:srgbClr val="FFFFFF"/>
                 </a:solidFill>
@@ -4957,9 +4957,9 @@
                 <a:ea typeface="Cambria" pitchFamily="34" charset="-122"/>
                 <a:cs typeface="Cambria" pitchFamily="34" charset="-120"/>
               </a:rPr>
-              <a:t>Elicitation format, product configuration, and turn structure are mutually confounded across these four studies.</a:t>
-            </a:r>
-            <a:endParaRPr lang="en-US" sz="1500" dirty="0"/>
+              <a:t>Elicitation format, product configuration and turn structure are mutually confounded here.</a:t>
+            </a:r>
+            <a:endParaRPr lang="en-US" sz="1450" dirty="0"/>
           </a:p>
         </p:txBody>
       </p:sp>
@@ -5010,24 +5010,24 @@
         </p:nvSpPr>
         <p:spPr>
           <a:xfrm>
-            <a:off x="548640" y="6400800"/>
-            <a:ext cx="11091672" cy="310896"/>
-          </a:xfrm>
-          <a:prstGeom prst="rect">
-            <a:avLst/>
-          </a:prstGeom>
-          <a:noFill/>
-          <a:ln/>
-        </p:spPr>
-        <p:txBody>
-          <a:bodyPr wrap="square" lIns="0" tIns="0" rIns="0" bIns="0" rtlCol="0" anchor="ctr"/>
-          <a:lstStyle/>
-          <a:p>
-            <a:pPr indent="0" marL="0">
-              <a:buNone/>
-            </a:pPr>
-            <a:r>
-              <a:rPr lang="en-US" sz="900" dirty="0">
+            <a:off x="548640" y="6309360"/>
+            <a:ext cx="11091672" cy="411480"/>
+          </a:xfrm>
+          <a:prstGeom prst="rect">
+            <a:avLst/>
+          </a:prstGeom>
+          <a:noFill/>
+          <a:ln/>
+        </p:spPr>
+        <p:txBody>
+          <a:bodyPr wrap="square" lIns="0" tIns="0" rIns="0" bIns="0" rtlCol="0" anchor="ctr"/>
+          <a:lstStyle/>
+          <a:p>
+            <a:pPr indent="0" marL="0">
+              <a:buNone/>
+            </a:pPr>
+            <a:r>
+              <a:rPr lang="en-US" sz="850" dirty="0">
                 <a:solidFill>
                   <a:srgbClr val="5A6B7C"/>
                 </a:solidFill>
@@ -5035,9 +5035,9 @@
                 <a:ea typeface="Calibri" pitchFamily="34" charset="-122"/>
                 <a:cs typeface="Calibri" pitchFamily="34" charset="-120"/>
               </a:rPr>
-              <a:t>Three of four are preprints — flagged as such. The authors' own explanation: peer review runs slower than model generations, so a protocol citing only reviewed work cites a superseded generation.</a:t>
-            </a:r>
-            <a:endParaRPr lang="en-US" sz="900" dirty="0"/>
+              <a:t>Three of four are preprints, flagged as such — peer review runs slower than model generations, so citing only reviewed work cites a superseded generation.</a:t>
+            </a:r>
+            <a:endParaRPr lang="en-US" sz="850" dirty="0"/>
           </a:p>
         </p:txBody>
       </p:sp>
@@ -6329,24 +6329,24 @@
         </p:nvSpPr>
         <p:spPr>
           <a:xfrm>
-            <a:off x="548640" y="6400800"/>
-            <a:ext cx="11091672" cy="310896"/>
-          </a:xfrm>
-          <a:prstGeom prst="rect">
-            <a:avLst/>
-          </a:prstGeom>
-          <a:noFill/>
-          <a:ln/>
-        </p:spPr>
-        <p:txBody>
-          <a:bodyPr wrap="square" lIns="0" tIns="0" rIns="0" bIns="0" rtlCol="0" anchor="ctr"/>
-          <a:lstStyle/>
-          <a:p>
-            <a:pPr indent="0" marL="0">
-              <a:buNone/>
-            </a:pPr>
-            <a:r>
-              <a:rPr lang="en-US" sz="900" dirty="0">
+            <a:off x="548640" y="6309360"/>
+            <a:ext cx="11091672" cy="411480"/>
+          </a:xfrm>
+          <a:prstGeom prst="rect">
+            <a:avLst/>
+          </a:prstGeom>
+          <a:noFill/>
+          <a:ln/>
+        </p:spPr>
+        <p:txBody>
+          <a:bodyPr wrap="square" lIns="0" tIns="0" rIns="0" bIns="0" rtlCol="0" anchor="ctr"/>
+          <a:lstStyle/>
+          <a:p>
+            <a:pPr indent="0" marL="0">
+              <a:buNone/>
+            </a:pPr>
+            <a:r>
+              <a:rPr lang="en-US" sz="850" dirty="0">
                 <a:solidFill>
                   <a:srgbClr val="5A6B7C"/>
                 </a:solidFill>
@@ -6356,7 +6356,7 @@
               </a:rPr>
               <a:t>Cue-locus factor (Change 12) is proposed for this cycle; its power calculation is gated on pilot discordance data and no power figures are stated until those exist.</a:t>
             </a:r>
-            <a:endParaRPr lang="en-US" sz="900" dirty="0"/>
+            <a:endParaRPr lang="en-US" sz="850" dirty="0"/>
           </a:p>
         </p:txBody>
       </p:sp>
@@ -6487,7 +6487,7 @@
             </a:avLst>
           </a:prstGeom>
           <a:solidFill>
-            <a:srgbClr val="81F0EC"/>
+            <a:srgbClr val="E0F0EC"/>
           </a:solidFill>
           <a:ln w="9525">
             <a:solidFill>
@@ -6898,24 +6898,24 @@
         </p:nvSpPr>
         <p:spPr>
           <a:xfrm>
-            <a:off x="548640" y="6400800"/>
-            <a:ext cx="11091672" cy="310896"/>
-          </a:xfrm>
-          <a:prstGeom prst="rect">
-            <a:avLst/>
-          </a:prstGeom>
-          <a:noFill/>
-          <a:ln/>
-        </p:spPr>
-        <p:txBody>
-          <a:bodyPr wrap="square" lIns="0" tIns="0" rIns="0" bIns="0" rtlCol="0" anchor="ctr"/>
-          <a:lstStyle/>
-          <a:p>
-            <a:pPr indent="0" marL="0">
-              <a:buNone/>
-            </a:pPr>
-            <a:r>
-              <a:rPr lang="en-US" sz="900" dirty="0">
+            <a:off x="548640" y="6309360"/>
+            <a:ext cx="11091672" cy="411480"/>
+          </a:xfrm>
+          <a:prstGeom prst="rect">
+            <a:avLst/>
+          </a:prstGeom>
+          <a:noFill/>
+          <a:ln/>
+        </p:spPr>
+        <p:txBody>
+          <a:bodyPr wrap="square" lIns="0" tIns="0" rIns="0" bIns="0" rtlCol="0" anchor="ctr"/>
+          <a:lstStyle/>
+          <a:p>
+            <a:pPr indent="0" marL="0">
+              <a:buNone/>
+            </a:pPr>
+            <a:r>
+              <a:rPr lang="en-US" sz="850" dirty="0">
                 <a:solidFill>
                   <a:srgbClr val="5A6B7C"/>
                 </a:solidFill>
@@ -6925,7 +6925,7 @@
               </a:rPr>
               <a:t>Key Features methodology: Medical Council of Canada, ~30 years of psychometric validation; 50 cases projects Cronbach's α ≈ 0.70–0.80 against the MCC's 32-case licensing threshold.</a:t>
             </a:r>
-            <a:endParaRPr lang="en-US" sz="900" dirty="0"/>
+            <a:endParaRPr lang="en-US" sz="850" dirty="0"/>
           </a:p>
         </p:txBody>
       </p:sp>
@@ -7501,24 +7501,24 @@
         </p:nvSpPr>
         <p:spPr>
           <a:xfrm>
-            <a:off x="8796528" y="1737360"/>
-            <a:ext cx="2642616" cy="548640"/>
-          </a:xfrm>
-          <a:prstGeom prst="rect">
-            <a:avLst/>
-          </a:prstGeom>
-          <a:noFill/>
-          <a:ln/>
-        </p:spPr>
-        <p:txBody>
-          <a:bodyPr wrap="square" lIns="0" tIns="0" rIns="0" bIns="0" rtlCol="0" anchor="ctr"/>
-          <a:lstStyle/>
-          <a:p>
-            <a:pPr indent="0" marL="0">
-              <a:buNone/>
-            </a:pPr>
-            <a:r>
-              <a:rPr lang="en-US" sz="1400" b="1" dirty="0">
+            <a:off x="8796528" y="1719072"/>
+            <a:ext cx="2642616" cy="566928"/>
+          </a:xfrm>
+          <a:prstGeom prst="rect">
+            <a:avLst/>
+          </a:prstGeom>
+          <a:noFill/>
+          <a:ln/>
+        </p:spPr>
+        <p:txBody>
+          <a:bodyPr wrap="square" lIns="0" tIns="0" rIns="0" bIns="0" rtlCol="0" anchor="t"/>
+          <a:lstStyle/>
+          <a:p>
+            <a:pPr indent="0" marL="0">
+              <a:buNone/>
+            </a:pPr>
+            <a:r>
+              <a:rPr lang="en-US" sz="1350" b="1" dirty="0">
                 <a:solidFill>
                   <a:srgbClr val="FFFFFF"/>
                 </a:solidFill>
@@ -7528,7 +7528,7 @@
               </a:rPr>
               <a:t>Why the ensemble is never sovereign</a:t>
             </a:r>
-            <a:endParaRPr lang="en-US" sz="1400" dirty="0"/>
+            <a:endParaRPr lang="en-US" sz="1350" dirty="0"/>
           </a:p>
         </p:txBody>
       </p:sp>
@@ -7540,8 +7540,8 @@
         </p:nvSpPr>
         <p:spPr>
           <a:xfrm>
-            <a:off x="8796528" y="2240280"/>
-            <a:ext cx="2642616" cy="3108960"/>
+            <a:off x="8796528" y="2340864"/>
+            <a:ext cx="2642616" cy="3017520"/>
           </a:xfrm>
           <a:prstGeom prst="rect">
             <a:avLst/>
@@ -7555,12 +7555,12 @@
           <a:p>
             <a:pPr indent="0" marL="0">
               <a:spcAft>
-                <a:spcPts val="900"/>
+                <a:spcPts val="800"/>
               </a:spcAft>
               <a:buNone/>
             </a:pPr>
             <a:r>
-              <a:rPr lang="en-US" sz="1020" dirty="0">
+              <a:rPr lang="en-US" sz="960" dirty="0">
                 <a:solidFill>
                   <a:srgbClr val="C6D5E1"/>
                 </a:solidFill>
@@ -7568,19 +7568,19 @@
                 <a:ea typeface="Calibri" pitchFamily="34" charset="-122"/>
                 <a:cs typeface="Calibri" pitchFamily="34" charset="-120"/>
               </a:rPr>
-              <a:t>Our own Phase 1: five AI evaluators scoring the same outputs spread ~13–14 points, with one platform systematically harsher.</a:t>
-            </a:r>
-            <a:endParaRPr lang="en-US" sz="1020" dirty="0"/>
+              <a:t>Our own Phase 1: five AI evaluators scoring the same outputs spread ~13–14 points, one platform systematically harsher.</a:t>
+            </a:r>
+            <a:endParaRPr lang="en-US" sz="960" dirty="0"/>
           </a:p>
           <a:p>
             <a:pPr indent="0" marL="0">
               <a:spcAft>
-                <a:spcPts val="900"/>
+                <a:spcPts val="800"/>
               </a:spcAft>
               <a:buNone/>
             </a:pPr>
             <a:r>
-              <a:rPr lang="en-US" sz="1020" dirty="0">
+              <a:rPr lang="en-US" sz="960" dirty="0">
                 <a:solidFill>
                   <a:srgbClr val="C6D5E1"/>
                 </a:solidFill>
@@ -7588,19 +7588,19 @@
                 <a:ea typeface="Calibri" pitchFamily="34" charset="-122"/>
                 <a:cs typeface="Calibri" pitchFamily="34" charset="-120"/>
               </a:rPr>
-              <a:t>NOHARM accepted its autograder only because κ vs physicians (0.804) matched inter-physician κ (0.784). We adopt that bar verbatim.</a:t>
-            </a:r>
-            <a:endParaRPr lang="en-US" sz="1020" dirty="0"/>
+              <a:t>NOHARM accepted its autograder only because κ vs physicians (0.804) matched inter-physician κ (0.784). We adopt that bar.</a:t>
+            </a:r>
+            <a:endParaRPr lang="en-US" sz="960" dirty="0"/>
           </a:p>
           <a:p>
             <a:pPr indent="0" marL="0">
               <a:spcAft>
-                <a:spcPts val="900"/>
+                <a:spcPts val="800"/>
               </a:spcAft>
               <a:buNone/>
             </a:pPr>
             <a:r>
-              <a:rPr lang="en-US" sz="1020" dirty="0">
+              <a:rPr lang="en-US" sz="960" dirty="0">
                 <a:solidFill>
                   <a:srgbClr val="C6D5E1"/>
                 </a:solidFill>
@@ -7608,16 +7608,16 @@
                 <a:ea typeface="Calibri" pitchFamily="34" charset="-122"/>
                 <a:cs typeface="Calibri" pitchFamily="34" charset="-120"/>
               </a:rPr>
-              <a:t>Multi-agent panels can reach false consensus: coordinated adversaries drove harmful-recommendation rates to 100% in unprotected systems, and a guideline-checking verifier restored accuracy (Han &amp; Shamszaman, preprint).</a:t>
-            </a:r>
-            <a:endParaRPr lang="en-US" sz="1020" dirty="0"/>
-          </a:p>
-          <a:p>
-            <a:pPr indent="0" marL="0">
-              <a:buNone/>
-            </a:pPr>
-            <a:r>
-              <a:rPr lang="en-US" sz="1020" b="1" dirty="0">
+              <a:t>Panels can reach false consensus: coordinated adversaries drove harmful-recommendation rates to 100%; a guideline-checking verifier restored accuracy (Han &amp; Shamszaman, preprint).</a:t>
+            </a:r>
+            <a:endParaRPr lang="en-US" sz="960" dirty="0"/>
+          </a:p>
+          <a:p>
+            <a:pPr indent="0" marL="0">
+              <a:buNone/>
+            </a:pPr>
+            <a:r>
+              <a:rPr lang="en-US" sz="960" b="1" dirty="0">
                 <a:solidFill>
                   <a:srgbClr val="8FD3C6"/>
                 </a:solidFill>
@@ -7625,9 +7625,9 @@
                 <a:ea typeface="Calibri" pitchFamily="34" charset="-122"/>
                 <a:cs typeface="Calibri" pitchFamily="34" charset="-120"/>
               </a:rPr>
-              <a:t>Hence: cross-vendor for uncorrelated error, deterministic layer as the verifier, humans holding harm.</a:t>
-            </a:r>
-            <a:endParaRPr lang="en-US" sz="1020" dirty="0"/>
+              <a:t>Hence: cross-vendor for uncorrelated error, deterministic layer as verifier, humans holding harm.</a:t>
+            </a:r>
+            <a:endParaRPr lang="en-US" sz="960" dirty="0"/>
           </a:p>
         </p:txBody>
       </p:sp>
@@ -7639,24 +7639,24 @@
         </p:nvSpPr>
         <p:spPr>
           <a:xfrm>
-            <a:off x="548640" y="6400800"/>
-            <a:ext cx="11091672" cy="310896"/>
-          </a:xfrm>
-          <a:prstGeom prst="rect">
-            <a:avLst/>
-          </a:prstGeom>
-          <a:noFill/>
-          <a:ln/>
-        </p:spPr>
-        <p:txBody>
-          <a:bodyPr wrap="square" lIns="0" tIns="0" rIns="0" bIns="0" rtlCol="0" anchor="ctr"/>
-          <a:lstStyle/>
-          <a:p>
-            <a:pPr indent="0" marL="0">
-              <a:buNone/>
-            </a:pPr>
-            <a:r>
-              <a:rPr lang="en-US" sz="900" dirty="0">
+            <a:off x="548640" y="6309360"/>
+            <a:ext cx="11091672" cy="411480"/>
+          </a:xfrm>
+          <a:prstGeom prst="rect">
+            <a:avLst/>
+          </a:prstGeom>
+          <a:noFill/>
+          <a:ln/>
+        </p:spPr>
+        <p:txBody>
+          <a:bodyPr wrap="square" lIns="0" tIns="0" rIns="0" bIns="0" rtlCol="0" anchor="ctr"/>
+          <a:lstStyle/>
+          <a:p>
+            <a:pPr indent="0" marL="0">
+              <a:buNone/>
+            </a:pPr>
+            <a:r>
+              <a:rPr lang="en-US" sz="850" dirty="0">
                 <a:solidFill>
                   <a:srgbClr val="5A6B7C"/>
                 </a:solidFill>
@@ -7664,9 +7664,9 @@
                 <a:ea typeface="Calibri" pitchFamily="34" charset="-122"/>
                 <a:cs typeface="Calibri" pitchFamily="34" charset="-120"/>
               </a:rPr>
-              <a:t>Adjudication workflow after Livingston et al., JAMIA Open 2025. Agreement: Gwet AC1 primary (κ unstable at the skewed prevalence expected for safety-critical tags), weighted κ secondary, Krippendorff α for the full panel.</a:t>
-            </a:r>
-            <a:endParaRPr lang="en-US" sz="900" dirty="0"/>
+              <a:t>Adjudication after Livingston et al., JAMIA Open 2025. Agreement: Gwet AC1 primary (κ unstable at skewed prevalence), weighted κ secondary, Krippendorff α panel-wide.</a:t>
+            </a:r>
+            <a:endParaRPr lang="en-US" sz="850" dirty="0"/>
           </a:p>
         </p:txBody>
       </p:sp>
@@ -9061,24 +9061,24 @@
         </p:nvSpPr>
         <p:spPr>
           <a:xfrm>
-            <a:off x="548640" y="6400800"/>
-            <a:ext cx="11091672" cy="310896"/>
-          </a:xfrm>
-          <a:prstGeom prst="rect">
-            <a:avLst/>
-          </a:prstGeom>
-          <a:noFill/>
-          <a:ln/>
-        </p:spPr>
-        <p:txBody>
-          <a:bodyPr wrap="square" lIns="0" tIns="0" rIns="0" bIns="0" rtlCol="0" anchor="ctr"/>
-          <a:lstStyle/>
-          <a:p>
-            <a:pPr indent="0" marL="0">
-              <a:buNone/>
-            </a:pPr>
-            <a:r>
-              <a:rPr lang="en-US" sz="900" dirty="0">
+            <a:off x="548640" y="6309360"/>
+            <a:ext cx="11091672" cy="411480"/>
+          </a:xfrm>
+          <a:prstGeom prst="rect">
+            <a:avLst/>
+          </a:prstGeom>
+          <a:noFill/>
+          <a:ln/>
+        </p:spPr>
+        <p:txBody>
+          <a:bodyPr wrap="square" lIns="0" tIns="0" rIns="0" bIns="0" rtlCol="0" anchor="ctr"/>
+          <a:lstStyle/>
+          <a:p>
+            <a:pPr indent="0" marL="0">
+              <a:buNone/>
+            </a:pPr>
+            <a:r>
+              <a:rPr lang="en-US" sz="850" dirty="0">
                 <a:solidFill>
                   <a:srgbClr val="5A6B7C"/>
                 </a:solidFill>
@@ -9086,9 +9086,9 @@
                 <a:ea typeface="Calibri" pitchFamily="34" charset="-122"/>
                 <a:cs typeface="Calibri" pitchFamily="34" charset="-120"/>
               </a:rPr>
-              <a:t>Residual and uncontrolled: consumer products route internally (reasoning vs fast paths) in ways we cannot observe or fix; vignettes are not real patient encounters; the physician answering panel is a comparator, not a ground truth.</a:t>
-            </a:r>
-            <a:endParaRPr lang="en-US" sz="900" dirty="0"/>
+              <a:t>Residual and uncontrolled: consumer products route internally (reasoning vs fast paths) unobservably; vignettes are not real encounters; the answering panel is a comparator, not ground truth.</a:t>
+            </a:r>
+            <a:endParaRPr lang="en-US" sz="850" dirty="0"/>
           </a:p>
         </p:txBody>
       </p:sp>
@@ -9364,7 +9364,7 @@
             </a:avLst>
           </a:prstGeom>
           <a:solidFill>
-            <a:srgbClr val="81F0EC"/>
+            <a:srgbClr val="E0F0EC"/>
           </a:solidFill>
           <a:ln w="9525">
             <a:solidFill>
@@ -9637,24 +9637,24 @@
         </p:nvSpPr>
         <p:spPr>
           <a:xfrm>
-            <a:off x="548640" y="6400800"/>
-            <a:ext cx="11091672" cy="310896"/>
-          </a:xfrm>
-          <a:prstGeom prst="rect">
-            <a:avLst/>
-          </a:prstGeom>
-          <a:noFill/>
-          <a:ln/>
-        </p:spPr>
-        <p:txBody>
-          <a:bodyPr wrap="square" lIns="0" tIns="0" rIns="0" bIns="0" rtlCol="0" anchor="ctr"/>
-          <a:lstStyle/>
-          <a:p>
-            <a:pPr indent="0" marL="0">
-              <a:buNone/>
-            </a:pPr>
-            <a:r>
-              <a:rPr lang="en-US" sz="900" dirty="0">
+            <a:off x="548640" y="6309360"/>
+            <a:ext cx="11091672" cy="411480"/>
+          </a:xfrm>
+          <a:prstGeom prst="rect">
+            <a:avLst/>
+          </a:prstGeom>
+          <a:noFill/>
+          <a:ln/>
+        </p:spPr>
+        <p:txBody>
+          <a:bodyPr wrap="square" lIns="0" tIns="0" rIns="0" bIns="0" rtlCol="0" anchor="ctr"/>
+          <a:lstStyle/>
+          <a:p>
+            <a:pPr indent="0" marL="0">
+              <a:buNone/>
+            </a:pPr>
+            <a:r>
+              <a:rPr lang="en-US" sz="850" dirty="0">
                 <a:solidFill>
                   <a:srgbClr val="5A6B7C"/>
                 </a:solidFill>
@@ -9664,7 +9664,7 @@
               </a:rPr>
               <a:t>Reporting to TRIPOD-LLM. Universal-referral rate reported per configuration so any scaffold benefit reads as an operating-point shift rather than blanket escalation.</a:t>
             </a:r>
-            <a:endParaRPr lang="en-US" sz="900" dirty="0"/>
+            <a:endParaRPr lang="en-US" sz="850" dirty="0"/>
           </a:p>
         </p:txBody>
       </p:sp>
@@ -10186,23 +10186,23 @@
         </p:nvSpPr>
         <p:spPr>
           <a:xfrm>
-            <a:off x="548640" y="6400800"/>
-            <a:ext cx="11091672" cy="310896"/>
-          </a:xfrm>
-          <a:prstGeom prst="rect">
-            <a:avLst/>
-          </a:prstGeom>
-          <a:noFill/>
-          <a:ln/>
-        </p:spPr>
-        <p:txBody>
-          <a:bodyPr wrap="square" lIns="0" tIns="0" rIns="0" bIns="0" rtlCol="0" anchor="ctr"/>
-          <a:lstStyle/>
-          <a:p>
-            <a:pPr indent="0" marL="0">
-              <a:buNone/>
-            </a:pPr>
-            <a:endParaRPr lang="en-US" sz="900" dirty="0"/>
+            <a:off x="548640" y="6309360"/>
+            <a:ext cx="11091672" cy="411480"/>
+          </a:xfrm>
+          <a:prstGeom prst="rect">
+            <a:avLst/>
+          </a:prstGeom>
+          <a:noFill/>
+          <a:ln/>
+        </p:spPr>
+        <p:txBody>
+          <a:bodyPr wrap="square" lIns="0" tIns="0" rIns="0" bIns="0" rtlCol="0" anchor="ctr"/>
+          <a:lstStyle/>
+          <a:p>
+            <a:pPr indent="0" marL="0">
+              <a:buNone/>
+            </a:pPr>
+            <a:endParaRPr lang="en-US" sz="850" dirty="0"/>
           </a:p>
         </p:txBody>
       </p:sp>

</xml_diff>